<commit_message>
feat(forensic): Thêm DTMFForensic, DTMFLine, tổng đài đọc lại phím; rà soát và sửa tài liệu
- Thêm vào git các tệp còn thiếu: DTMFForensic, DTMFLive, DTMFLine, dtmf_judge,
  ui_pad, ui_live_draw, bốn test mới, web/src/forensic, hình H3_4, H3_5, SD_duong_day.
- Web: trang điện thoại không còn cướp đường dây của màn giám định (hỏi
  trạng thái trước khi gọi); useWire bỏ kết quả của lượt nối cũ; DtmfPlayer.close.
- Web: tổng đài đổi sang chào một lần rồi đọc lại từng phím, theo kịch bản thu âm.
- MATLAB: đồng hồ tự dọn khi cửa sổ mất; ngắt đường dây giữa vụ thì hủy vụ;
  DTMFLive báo app = live.
- CONTRACTS: dung sai tần số đo được (nhận chắc ±0,5%, loại ±3,5%), mục 7.12.
- Báo cáo: 241 ca MATLAB và 62 ca web, thêm mục DTMFForensic, sửa bìa, URL,
  hạn chế dung sai và nhận nhầm, chụp lại H3_5.
- README, ui_naming, README báo cáo, .gitignore, slide (số ca kiểm thử).
</commit_message>
<xml_diff>
--- a/slides/Hệ thống phát và giải mã tín hiệu DTMF.pptx
+++ b/slides/Hệ thống phát và giải mã tín hiệu DTMF.pptx
@@ -3914,7 +3914,7 @@
                 <a:ea typeface="Tinos" pitchFamily="34" charset="-122"/>
                 <a:cs typeface="Times New Roman" panose="02020603050405020304" pitchFamily="18" charset="0"/>
               </a:rPr>
-              <a:t>162</a:t>
+              <a:t>241</a:t>
             </a:r>
             <a:endParaRPr lang="en-US" sz="5200" dirty="0">
               <a:latin typeface="Times New Roman" panose="02020603050405020304" pitchFamily="18" charset="0"/>
@@ -9775,7 +9775,7 @@
                 <a:ea typeface="Open Sans" pitchFamily="34" charset="-122"/>
                 <a:cs typeface="Times New Roman" panose="02020603050405020304" pitchFamily="18" charset="0"/>
               </a:rPr>
-              <a:t>Giao diện trực quan, 162 ca kiểm thử</a:t>
+              <a:t>Giao diện trực quan, 241 ca kiểm thử</a:t>
             </a:r>
             <a:endParaRPr lang="en-US" sz="1600" dirty="0">
               <a:latin typeface="Times New Roman" panose="02020603050405020304" pitchFamily="18" charset="0"/>
@@ -10370,7 +10370,7 @@
                 <a:ea typeface="Open Sans" pitchFamily="34" charset="-122"/>
                 <a:cs typeface="Times New Roman" panose="02020603050405020304" pitchFamily="18" charset="0"/>
               </a:rPr>
-              <a:t>Hỏi &amp; đáp · Demo trực tiếp DTMFApp</a:t>
+              <a:t>Hỏi &amp; đáp · Demo trực tiếp DTMFApp, DTMFLive, DTMFForensic</a:t>
             </a:r>
             <a:endParaRPr lang="en-US" sz="2000" dirty="0">
               <a:latin typeface="Times New Roman" panose="02020603050405020304" pitchFamily="18" charset="0"/>
@@ -11850,7 +11850,7 @@
                 <a:ea typeface="Open Sans" pitchFamily="34" charset="-122"/>
                 <a:cs typeface="Times New Roman" panose="02020603050405020304" pitchFamily="18" charset="0"/>
               </a:rPr>
-              <a:t>162 ca kiểm thử</a:t>
+              <a:t>241 ca kiểm thử</a:t>
             </a:r>
             <a:endParaRPr lang="en-US" sz="1500" dirty="0">
               <a:latin typeface="Times New Roman" panose="02020603050405020304" pitchFamily="18" charset="0"/>

</xml_diff>

<commit_message>
feat(app): Nhập tín hiệu từ tệp âm thanh trong DTMFApp
Đề Chủ đề 4 cho phép "nhập từ file audio"; trước đây chỉ có chuỗi phím và micro.

- app/dtmf_readaudio.m: audioread, gộp kênh, resample về 8 kHz, cắt tối đa 60 s.
- DTMFApp: nút "Mở tệp âm thanh…" ở bước 1, method napTep; tệp thành x[n],
  bước 2 và 3 như tín hiệu tổng hợp, dòng trạng thái báo số phím đọc được.
- Test: test_readaudio (4 ca), test_app_smoke thêm 4 ca; tổng 249 ca.
- Cập nhật README, CONTRACTS, ui_naming, báo cáo (H3_3, lưu đồ, bảng hàm,
  số ca kiểm thử) và slide.
</commit_message>
<xml_diff>
--- a/slides/Hệ thống phát và giải mã tín hiệu DTMF.pptx
+++ b/slides/Hệ thống phát và giải mã tín hiệu DTMF.pptx
@@ -3914,7 +3914,7 @@
                 <a:ea typeface="Tinos" pitchFamily="34" charset="-122"/>
                 <a:cs typeface="Times New Roman" panose="02020603050405020304" pitchFamily="18" charset="0"/>
               </a:rPr>
-              <a:t>241</a:t>
+              <a:t>249</a:t>
             </a:r>
             <a:endParaRPr lang="en-US" sz="5200" dirty="0">
               <a:latin typeface="Times New Roman" panose="02020603050405020304" pitchFamily="18" charset="0"/>
@@ -9775,7 +9775,7 @@
                 <a:ea typeface="Open Sans" pitchFamily="34" charset="-122"/>
                 <a:cs typeface="Times New Roman" panose="02020603050405020304" pitchFamily="18" charset="0"/>
               </a:rPr>
-              <a:t>Giao diện trực quan, 241 ca kiểm thử</a:t>
+              <a:t>Giao diện trực quan, 249 ca kiểm thử</a:t>
             </a:r>
             <a:endParaRPr lang="en-US" sz="1600" dirty="0">
               <a:latin typeface="Times New Roman" panose="02020603050405020304" pitchFamily="18" charset="0"/>
@@ -11850,7 +11850,7 @@
                 <a:ea typeface="Open Sans" pitchFamily="34" charset="-122"/>
                 <a:cs typeface="Times New Roman" panose="02020603050405020304" pitchFamily="18" charset="0"/>
               </a:rPr>
-              <a:t>241 ca kiểm thử</a:t>
+              <a:t>249 ca kiểm thử</a:t>
             </a:r>
             <a:endParaRPr lang="en-US" sz="1500" dirty="0">
               <a:latin typeface="Times New Roman" panose="02020603050405020304" pitchFamily="18" charset="0"/>

</xml_diff>

<commit_message>
feat: Thêm bộ dữ liệu WAV kiểm thử, rà soát mã nguồn, báo cáo và slide
</commit_message>
<xml_diff>
--- a/slides/Hệ thống phát và giải mã tín hiệu DTMF.pptx
+++ b/slides/Hệ thống phát và giải mã tín hiệu DTMF.pptx
@@ -560,7 +560,7 @@
           <a:p>
             <a:r>
               <a:rPr lang="en-US" dirty="0"/>
-              <a:t>Thiết lập: 20 chuỗi 12 phím, 15 mức SNR, hai loại nhiễu, cố định rng(2026). Độ chính xác acc bằng 1 trừ khoảng cách Levenshtein chia độ dài chuỗi dài hơn. Trong dải làm việc SNR từ 10 dB cả ba đều đúng hoàn toàn. Khác biệt ở SNR thấp: tại 2,5 dB ngân hàng lọc đạt 0,96, FFT chỉ 0,16. Với nhiễu ù 50 Hz: ngân hàng lọc 1,00, Goertzel 0,07, FFT 0,00.</a:t>
+              <a:t>Thiết lập: 20 chuỗi 12 phím, 15 mức SNR, hai loại nhiễu, cố định rng(2026). Độ chính xác acc bằng 1 trừ khoảng cách Levenshtein chia độ dài chuỗi dài hơn. Trong dải làm việc SNR từ 10 dB cả ba đều đúng hoàn toàn. Khác biệt ở SNR thấp: tại 2,5 dB ngân hàng lọc đạt 0,96, FFT chỉ 0,16. Với nhiễu điện lưới 50 Hz: ngân hàng lọc 1,00, Goertzel 0,07, FFT 0,00.</a:t>
             </a:r>
           </a:p>
         </p:txBody>
@@ -821,7 +821,7 @@
           <a:p>
             <a:r>
               <a:rPr lang="en-US" dirty="0"/>
-              <a:t>Goertzel: rẻ nhất, bộ nhớ chỉ 2 số thực mỗi bin, đúng 100% từ 7,5 dB, hợp với thiết bị nhúng và nhiễu vừa phải. Ngân hàng lọc: bền nhiễu nhất, là cách duy nhất đạt 1,00 với nhiễu ù ở 2,5 dB, nhưng đắt nhất. FFT: dễ cài đặt nhất, cho phổ đầy đủ, nhưng kém bền nhiễu nhất ở SNR thấp.</a:t>
+              <a:t>Goertzel: ít phép nhân nhất, bộ nhớ chỉ 2 số thực mỗi bin, đúng 100% từ 7,5 dB, hợp với thiết bị nhúng và nhiễu vừa phải. Ngân hàng lọc: bền nhiễu nhất, là cách duy nhất đạt 1,00 với nhiễu điện lưới ở 2,5 dB, nhưng tốn phép nhân nhất. FFT: dễ cài đặt nhất, cho phổ đầy đủ, nhưng kém bền nhiễu nhất ở SNR thấp.</a:t>
             </a:r>
           </a:p>
         </p:txBody>
@@ -908,7 +908,7 @@
           <a:p>
             <a:r>
               <a:rPr lang="en-US" dirty="0"/>
-              <a:t>Kết quả: bộ phát theo ITU-T Q.23/Q.24, ba bộ giải mã chung chữ ký và luật quyết định, tự cài đặt Goertzel và bộ lọc cộng hưởng, so sánh trên 5400 điều kiện. Hạn chế: mới dùng dữ liệu tổng hợp, chưa chạy thời gian thực, chưa đo khả năng chống nhận nhầm tiếng nói. Các hướng phát triển khắc phục lần lượt từng điểm.</a:t>
+              <a:t>Kết quả: bộ phát theo ITU-T Q.23/Q.24, ba bộ giải mã chung chữ ký và tiêu chí chấp nhận khung, tự cài đặt Goertzel và bộ lọc cộng hưởng, so sánh trên 5400 lượt giải mã. Hạn chế: thực nghiệm định lượng mới dùng dữ liệu tổng hợp, giọng nói thật mới có một giọng dài 18 giây, chuẩn Q.24 mới đạt một phần, và ngân hàng lọc còn sinh phím giả từ dao động dư. Các hướng phát triển khắc phục lần lượt từng điểm.</a:t>
             </a:r>
           </a:p>
         </p:txBody>
@@ -2618,7 +2618,7 @@
                 <a:ea typeface="Tinos" pitchFamily="34" charset="-122"/>
                 <a:cs typeface="Times New Roman" panose="02020603050405020304" pitchFamily="18" charset="0"/>
               </a:rPr>
-              <a:t>Luật quyết định dùng chung</a:t>
+              <a:t>Tiêu chí chấp nhận khung</a:t>
             </a:r>
             <a:endParaRPr lang="en-US" sz="4400" dirty="0">
               <a:latin typeface="Times New Roman" panose="02020603050405020304" pitchFamily="18" charset="0"/>
@@ -3807,13 +3807,13 @@
         </p:nvPicPr>
         <p:blipFill>
           <a:blip r:embed="rId3"/>
-          <a:srcRect l="-100" r="-100"/>
+          <a:srcRect/>
           <a:stretch/>
         </p:blipFill>
         <p:spPr>
           <a:xfrm>
-            <a:off x="825500" y="2260662"/>
-            <a:ext cx="6324600" cy="3854450"/>
+            <a:off x="825500" y="2348003"/>
+            <a:ext cx="6324600" cy="3679767"/>
           </a:xfrm>
           <a:prstGeom prst="roundRect">
             <a:avLst>
@@ -3914,7 +3914,7 @@
                 <a:ea typeface="Tinos" pitchFamily="34" charset="-122"/>
                 <a:cs typeface="Times New Roman" panose="02020603050405020304" pitchFamily="18" charset="0"/>
               </a:rPr>
-              <a:t>249</a:t>
+              <a:t>266</a:t>
             </a:r>
             <a:endParaRPr lang="en-US" sz="5200" dirty="0">
               <a:latin typeface="Times New Roman" panose="02020603050405020304" pitchFamily="18" charset="0"/>
@@ -4031,7 +4031,7 @@
                 <a:ea typeface="Open Sans" pitchFamily="34" charset="-122"/>
                 <a:cs typeface="Times New Roman" panose="02020603050405020304" pitchFamily="18" charset="0"/>
               </a:rPr>
-              <a:t>3 đồ thị</a:t>
+              <a:t>6 hình theo 3 bước</a:t>
             </a:r>
             <a:endParaRPr lang="en-US" sz="1600" dirty="0">
               <a:latin typeface="Times New Roman" panose="02020603050405020304" pitchFamily="18" charset="0"/>
@@ -4078,7 +4078,7 @@
                 <a:ea typeface="Open Sans" pitchFamily="34" charset="-122"/>
                 <a:cs typeface="Times New Roman" panose="02020603050405020304" pitchFamily="18" charset="0"/>
               </a:rPr>
-              <a:t>Dạng sóng · phổ đồ · công suất 8 bin</a:t>
+              <a:t>Dạng sóng · phổ công suất · năng lượng 8 bin</a:t>
             </a:r>
             <a:endParaRPr lang="en-US" sz="1400" dirty="0">
               <a:latin typeface="Times New Roman" panose="02020603050405020304" pitchFamily="18" charset="0"/>
@@ -4434,7 +4434,7 @@
                 <a:ea typeface="Open Sans" pitchFamily="34" charset="-122"/>
                 <a:cs typeface="Times New Roman" panose="02020603050405020304" pitchFamily="18" charset="0"/>
               </a:rPr>
-              <a:t>Ngân hàng bộ lọc bền nhiễu nhất — </a:t>
+              <a:t>Ngân hàng bộ lọc bền nhiễu nhất, </a:t>
             </a:r>
             <a:r>
               <a:rPr lang="en-US" sz="1700" dirty="0">
@@ -4445,7 +4445,7 @@
                 <a:ea typeface="Open Sans" pitchFamily="34" charset="-122"/>
                 <a:cs typeface="Times New Roman" panose="02020603050405020304" pitchFamily="18" charset="0"/>
               </a:rPr>
-              <a:t>ngược với trực giác “FFT mạnh nhất”</a:t>
+              <a:t>nhờ đo đúng tại tần số chuẩn</a:t>
             </a:r>
             <a:endParaRPr lang="en-US" sz="1700" dirty="0">
               <a:latin typeface="Times New Roman" panose="02020603050405020304" pitchFamily="18" charset="0"/>
@@ -4707,7 +4707,7 @@
                 <a:ea typeface="Open Sans" pitchFamily="34" charset="-122"/>
                 <a:cs typeface="Times New Roman" panose="02020603050405020304" pitchFamily="18" charset="0"/>
               </a:rPr>
-              <a:t>ù 50 Hz</a:t>
+              <a:t>điện lưới</a:t>
             </a:r>
             <a:endParaRPr lang="en-US" sz="1300" dirty="0">
               <a:latin typeface="Times New Roman" panose="02020603050405020304" pitchFamily="18" charset="0"/>
@@ -4857,7 +4857,7 @@
                 <a:ea typeface="Open Sans" pitchFamily="34" charset="-122"/>
                 <a:cs typeface="Times New Roman" panose="02020603050405020304" pitchFamily="18" charset="0"/>
               </a:rPr>
-              <a:t>Độ chính xác theo SNR · trái: AWGN · phải: ù 50 Hz · nền xanh: SNR ≥ 10 dB</a:t>
+              <a:t>Độ chính xác theo SNR · trái: AWGN · phải: điện lưới 50 Hz · nền xanh: SNR ≥ 10 dB</a:t>
             </a:r>
             <a:endParaRPr lang="en-US" sz="1200" dirty="0">
               <a:latin typeface="Times New Roman" panose="02020603050405020304" pitchFamily="18" charset="0"/>
@@ -7472,7 +7472,7 @@
                 <a:ea typeface="Open Sans" pitchFamily="34" charset="-122"/>
                 <a:cs typeface="Times New Roman" panose="02020603050405020304" pitchFamily="18" charset="0"/>
               </a:rPr>
-              <a:t>nhanh hơn thời gian thực hàng trăm lần</a:t>
+              <a:t>nhanh gấp hàng trăm lần thời gian thực</a:t>
             </a:r>
             <a:r>
               <a:rPr lang="en-US" sz="1600" dirty="0">
@@ -7744,7 +7744,7 @@
                 <a:ea typeface="Open Sans" pitchFamily="34" charset="-122"/>
                 <a:cs typeface="Times New Roman" panose="02020603050405020304" pitchFamily="18" charset="0"/>
               </a:rPr>
-              <a:t>Không có phương pháp “tốt nhất” — </a:t>
+              <a:t>Không có phương pháp tốt nhất ở mọi mặt, </a:t>
             </a:r>
             <a:r>
               <a:rPr lang="en-US" sz="1700" dirty="0">
@@ -8242,7 +8242,7 @@
                 <a:ea typeface="Open Sans" pitchFamily="34" charset="-122"/>
                 <a:cs typeface="Times New Roman" panose="02020603050405020304" pitchFamily="18" charset="0"/>
               </a:rPr>
-              <a:t>phép nhân/s — rẻ nhất</a:t>
+              <a:t>phép nhân/s, ít nhất</a:t>
             </a:r>
             <a:endParaRPr lang="en-US" sz="1400" dirty="0">
               <a:latin typeface="Times New Roman" panose="02020603050405020304" pitchFamily="18" charset="0"/>
@@ -8453,7 +8453,7 @@
                 <a:ea typeface="Open Sans" pitchFamily="34" charset="-122"/>
                 <a:cs typeface="Times New Roman" panose="02020603050405020304" pitchFamily="18" charset="0"/>
               </a:rPr>
-              <a:t>Nhiễu mạnh, ù điện lưới</a:t>
+              <a:t>Nhiễu mạnh, nhiễu điện lưới</a:t>
             </a:r>
             <a:endParaRPr lang="en-US" sz="1700" dirty="0">
               <a:latin typeface="Times New Roman" panose="02020603050405020304" pitchFamily="18" charset="0"/>
@@ -8534,7 +8534,7 @@
                 <a:ea typeface="Open Sans" pitchFamily="34" charset="-122"/>
                 <a:cs typeface="Times New Roman" panose="02020603050405020304" pitchFamily="18" charset="0"/>
               </a:rPr>
-              <a:t> 1,00 với nhiễu ù 50 Hz</a:t>
+              <a:t> 1,00 với nhiễu điện lưới</a:t>
             </a:r>
             <a:endParaRPr lang="en-US" sz="1500" dirty="0">
               <a:latin typeface="Times New Roman" panose="02020603050405020304" pitchFamily="18" charset="0"/>
@@ -8592,7 +8592,7 @@
                 <a:ea typeface="Open Sans" pitchFamily="34" charset="-122"/>
                 <a:cs typeface="Times New Roman" panose="02020603050405020304" pitchFamily="18" charset="0"/>
               </a:rPr>
-              <a:t> Đắt nhất, khó cài nhất</a:t>
+              <a:t> Chi phí cao nhất, khó cài nhất</a:t>
             </a:r>
             <a:endParaRPr lang="en-US" sz="1500" dirty="0">
               <a:latin typeface="Times New Roman" panose="02020603050405020304" pitchFamily="18" charset="0"/>
@@ -9635,7 +9635,7 @@
                 <a:ea typeface="Open Sans" pitchFamily="34" charset="-122"/>
                 <a:cs typeface="Times New Roman" panose="02020603050405020304" pitchFamily="18" charset="0"/>
               </a:rPr>
-              <a:t>3 bộ giải mã, chung một luật quyết định</a:t>
+              <a:t>3 bộ giải mã, chung tiêu chí chấp nhận khung</a:t>
             </a:r>
             <a:endParaRPr lang="en-US" sz="1600" dirty="0">
               <a:latin typeface="Times New Roman" panose="02020603050405020304" pitchFamily="18" charset="0"/>
@@ -9775,7 +9775,7 @@
                 <a:ea typeface="Open Sans" pitchFamily="34" charset="-122"/>
                 <a:cs typeface="Times New Roman" panose="02020603050405020304" pitchFamily="18" charset="0"/>
               </a:rPr>
-              <a:t>Giao diện trực quan, 249 ca kiểm thử</a:t>
+              <a:t>Giao diện trực quan, 266 ca kiểm thử</a:t>
             </a:r>
             <a:endParaRPr lang="en-US" sz="1600" dirty="0">
               <a:latin typeface="Times New Roman" panose="02020603050405020304" pitchFamily="18" charset="0"/>
@@ -10370,7 +10370,7 @@
                 <a:ea typeface="Open Sans" pitchFamily="34" charset="-122"/>
                 <a:cs typeface="Times New Roman" panose="02020603050405020304" pitchFamily="18" charset="0"/>
               </a:rPr>
-              <a:t>Hỏi &amp; đáp · Demo trực tiếp DTMFApp, DTMFLive, DTMFForensic</a:t>
+              <a:t>Hỏi &amp; đáp · Demo trực tiếp</a:t>
             </a:r>
             <a:endParaRPr lang="en-US" sz="2000" dirty="0">
               <a:latin typeface="Times New Roman" panose="02020603050405020304" pitchFamily="18" charset="0"/>
@@ -10595,7 +10595,7 @@
                 <a:ea typeface="Tinos" pitchFamily="34" charset="-122"/>
                 <a:cs typeface="Times New Roman" panose="02020603050405020304" pitchFamily="18" charset="0"/>
               </a:rPr>
-              <a:t>Khi bấm một phím điện thoại, làm sao tổng đài “nghe” ra đó là phím nào — kể cả khi đường truyền có nhiễu?</a:t>
+              <a:t>Khi bấm một phím điện thoại, làm sao tổng đài “nghe” ra đó là phím nào, kể cả khi đường truyền có nhiễu?</a:t>
             </a:r>
             <a:endParaRPr lang="en-US" sz="2000" dirty="0">
               <a:latin typeface="Times New Roman" panose="02020603050405020304" pitchFamily="18" charset="0"/>
@@ -11602,7 +11602,7 @@
                 <a:ea typeface="Open Sans" pitchFamily="34" charset="-122"/>
                 <a:cs typeface="Times New Roman" panose="02020603050405020304" pitchFamily="18" charset="0"/>
               </a:rPr>
-              <a:t>Luật quyết định</a:t>
+              <a:t>Chấp nhận khung</a:t>
             </a:r>
             <a:endParaRPr lang="en-US" sz="1500" dirty="0">
               <a:latin typeface="Times New Roman" panose="02020603050405020304" pitchFamily="18" charset="0"/>
@@ -11850,7 +11850,7 @@
                 <a:ea typeface="Open Sans" pitchFamily="34" charset="-122"/>
                 <a:cs typeface="Times New Roman" panose="02020603050405020304" pitchFamily="18" charset="0"/>
               </a:rPr>
-              <a:t>249 ca kiểm thử</a:t>
+              <a:t>266 ca kiểm thử</a:t>
             </a:r>
             <a:endParaRPr lang="en-US" sz="1500" dirty="0">
               <a:latin typeface="Times New Roman" panose="02020603050405020304" pitchFamily="18" charset="0"/>
@@ -14260,7 +14260,7 @@
                 <a:ea typeface="Open Sans" pitchFamily="34" charset="-122"/>
                 <a:cs typeface="Times New Roman" panose="02020603050405020304" pitchFamily="18" charset="0"/>
               </a:rPr>
-              <a:t>fs = 8000 Hz · tone 100 ms · nghỉ 50 ms</a:t>
+              <a:t>fs = 8000 Hz · âm 100 ms · nghỉ 50 ms</a:t>
             </a:r>
             <a:endParaRPr lang="en-US" sz="1400" dirty="0">
               <a:latin typeface="Times New Roman" panose="02020603050405020304" pitchFamily="18" charset="0"/>
@@ -14831,7 +14831,7 @@
                 <a:ea typeface="Open Sans" pitchFamily="34" charset="-122"/>
                 <a:cs typeface="Times New Roman" panose="02020603050405020304" pitchFamily="18" charset="0"/>
               </a:rPr>
-              <a:t> AWGN / ù 50 Hz</a:t>
+              <a:t> AWGN / điện lưới 50 Hz</a:t>
             </a:r>
             <a:endParaRPr lang="en-US" sz="1500" dirty="0">
               <a:latin typeface="Times New Roman" panose="02020603050405020304" pitchFamily="18" charset="0"/>
@@ -15390,7 +15390,7 @@
                 <a:ea typeface="Open Sans" pitchFamily="34" charset="-122"/>
                 <a:cs typeface="Times New Roman" panose="02020603050405020304" pitchFamily="18" charset="0"/>
               </a:rPr>
-              <a:t> mọi bước — chỉ </a:t>
+              <a:t> mọi bước, chỉ </a:t>
             </a:r>
             <a:r>
               <a:rPr lang="en-US" sz="1700" dirty="0">
@@ -16431,7 +16431,7 @@
                 <a:ea typeface="Open Sans" pitchFamily="34" charset="-122"/>
                 <a:cs typeface="Times New Roman" panose="02020603050405020304" pitchFamily="18" charset="0"/>
               </a:rPr>
-              <a:t>65 000 · rẻ nhất</a:t>
+              <a:t>65 000 · ít nhất</a:t>
             </a:r>
             <a:endParaRPr lang="en-US" sz="1500" dirty="0">
               <a:latin typeface="Times New Roman" panose="02020603050405020304" pitchFamily="18" charset="0"/>
@@ -17311,7 +17311,7 @@
                 <a:ea typeface="Open Sans" pitchFamily="34" charset="-122"/>
                 <a:cs typeface="Times New Roman" panose="02020603050405020304" pitchFamily="18" charset="0"/>
               </a:rPr>
-              <a:t>Luật quyết định</a:t>
+              <a:t>Chấp nhận khung</a:t>
             </a:r>
             <a:endParaRPr lang="en-US" sz="1400" dirty="0">
               <a:latin typeface="Times New Roman" panose="02020603050405020304" pitchFamily="18" charset="0"/>
@@ -18473,7 +18473,7 @@
                 <a:ea typeface="Open Sans" pitchFamily="34" charset="-122"/>
                 <a:cs typeface="Times New Roman" panose="02020603050405020304" pitchFamily="18" charset="0"/>
               </a:rPr>
-              <a:t> — mỗi bin là một bộ lọc IIR bậc 2</a:t>
+              <a:t>, mỗi bin là một bộ lọc IIR bậc 2</a:t>
             </a:r>
             <a:endParaRPr lang="en-US" sz="1700" dirty="0">
               <a:latin typeface="Times New Roman" panose="02020603050405020304" pitchFamily="18" charset="0"/>
@@ -19177,7 +19177,7 @@
                 <a:ea typeface="Open Sans" pitchFamily="34" charset="-122"/>
                 <a:cs typeface="Times New Roman" panose="02020603050405020304" pitchFamily="18" charset="0"/>
               </a:rPr>
-              <a:t>Thì rẻ hơn FFT — DTMF chỉ cần 8</a:t>
+              <a:t>Ít phép nhân hơn FFT, DTMF chỉ cần 8</a:t>
             </a:r>
             <a:endParaRPr lang="en-US" sz="1500" dirty="0">
               <a:latin typeface="Times New Roman" panose="02020603050405020304" pitchFamily="18" charset="0"/>
@@ -20079,7 +20079,7 @@
                 <a:ea typeface="Open Sans" pitchFamily="34" charset="-122"/>
                 <a:cs typeface="Times New Roman" panose="02020603050405020304" pitchFamily="18" charset="0"/>
               </a:rPr>
-              <a:t> cho dải 25 Hz — IIR bậc 2 chỉ cần </a:t>
+              <a:t> cho dải 25 Hz, IIR bậc 2 chỉ cần </a:t>
             </a:r>
             <a:r>
               <a:rPr lang="en-US" sz="1600" dirty="0">

</xml_diff>